<commit_message>
Updated figure 1 draft
</commit_message>
<xml_diff>
--- a/figures/fig1_ecosystem_map/fig1_ecosystem_map_design.pptx
+++ b/figures/fig1_ecosystem_map/fig1_ecosystem_map_design.pptx
@@ -4,12 +4,12 @@
   <p:sldMasterIdLst>
     <p:sldMasterId id="2147483648" r:id="rId1"/>
   </p:sldMasterIdLst>
+  <p:notesMasterIdLst>
+    <p:notesMasterId r:id="rId3"/>
+  </p:notesMasterIdLst>
   <p:sldIdLst>
     <p:sldId id="256" r:id="rId2"/>
   </p:sldIdLst>
-  <p:notesMasterIdLst>
-    <p:notesMasterId r:id="rId3"/>
-  </p:notesMasterIdLst>
   <p:sldSz cx="12192000" cy="6858000"/>
   <p:notesSz cx="6858000" cy="12192000"/>
   <p:defaultTextStyle>
@@ -104,6 +104,11 @@
       </a:defRPr>
     </a:lvl9pPr>
   </p:defaultTextStyle>
+  <p:extLst>
+    <p:ext uri="{EFAFB233-063F-42B5-8137-9DF3F51BA10A}">
+      <p15:sldGuideLst xmlns:p15="http://schemas.microsoft.com/office/powerpoint/2012/main"/>
+    </p:ext>
+  </p:extLst>
 </p:presentation>
 </file>
 
@@ -129,234 +134,10 @@
           <a:chExt cx="0" cy="0"/>
         </a:xfrm>
       </p:grpSpPr>
-      <p:sp>
-        <p:nvSpPr>
-          <p:cNvPr id="2" name="Header Placeholder 1"/>
-          <p:cNvSpPr>
-            <a:spLocks noGrp="1"/>
-          </p:cNvSpPr>
-          <p:nvPr>
-            <p:ph type="hdr" sz="quarter"/>
-          </p:nvPr>
-        </p:nvSpPr>
-        <p:spPr>
-          <a:xfrm>
-            <a:off x="0" y="0"/>
-            <a:ext cx="2971800" cy="458788"/>
-          </a:xfrm>
-          <a:prstGeom prst="rect">
-            <a:avLst/>
-          </a:prstGeom>
-        </p:spPr>
-        <p:txBody>
-          <a:bodyPr vert="horz" lIns="91440" tIns="45720" rIns="91440" bIns="45720" rtlCol="0"/>
-          <a:lstStyle>
-            <a:lvl1pPr algn="l">
-              <a:defRPr sz="1200"/>
-            </a:lvl1pPr>
-          </a:lstStyle>
-          <a:p>
-            <a:endParaRPr lang="en-US"/>
-          </a:p>
-        </p:txBody>
-      </p:sp>
-      <p:sp>
-        <p:nvSpPr>
-          <p:cNvPr id="3" name="Date Placeholder 2"/>
-          <p:cNvSpPr>
-            <a:spLocks noGrp="1"/>
-          </p:cNvSpPr>
-          <p:nvPr>
-            <p:ph type="dt" idx="1"/>
-          </p:nvPr>
-        </p:nvSpPr>
-        <p:spPr>
-          <a:xfrm>
-            <a:off x="3884613" y="0"/>
-            <a:ext cx="2971800" cy="458788"/>
-          </a:xfrm>
-          <a:prstGeom prst="rect">
-            <a:avLst/>
-          </a:prstGeom>
-        </p:spPr>
-        <p:txBody>
-          <a:bodyPr vert="horz" lIns="91440" tIns="45720" rIns="91440" bIns="45720" rtlCol="0"/>
-          <a:lstStyle>
-            <a:lvl1pPr algn="r">
-              <a:defRPr sz="1200"/>
-            </a:lvl1pPr>
-          </a:lstStyle>
-          <a:p>
-            <a:fld id="{5282F153-3F37-0F45-9E97-73ACFA13230C}" type="datetimeFigureOut">
-              <a:rPr lang="en-US"/>
-              <a:t>7/23/19</a:t>
-            </a:fld>
-            <a:endParaRPr lang="en-US"/>
-          </a:p>
-        </p:txBody>
-      </p:sp>
-      <p:sp>
-        <p:nvSpPr>
-          <p:cNvPr id="4" name="Slide Image Placeholder 3"/>
-          <p:cNvSpPr>
-            <a:spLocks noGrp="1" noRot="1" noChangeAspect="1"/>
-          </p:cNvSpPr>
-          <p:nvPr>
-            <p:ph type="sldImg" idx="2"/>
-          </p:nvPr>
-        </p:nvSpPr>
-        <p:spPr>
-          <a:xfrm>
-            <a:off x="685800" y="1143000"/>
-            <a:ext cx="5486400" cy="3086100"/>
-          </a:xfrm>
-          <a:prstGeom prst="rect">
-            <a:avLst/>
-          </a:prstGeom>
-          <a:noFill/>
-          <a:ln w="12700">
-            <a:solidFill>
-              <a:prstClr val="black"/>
-            </a:solidFill>
-          </a:ln>
-        </p:spPr>
-        <p:txBody>
-          <a:bodyPr vert="horz" lIns="91440" tIns="45720" rIns="91440" bIns="45720" rtlCol="0" anchor="ctr"/>
-          <a:lstStyle/>
-          <a:p>
-            <a:endParaRPr lang="en-US"/>
-          </a:p>
-        </p:txBody>
-      </p:sp>
-      <p:sp>
-        <p:nvSpPr>
-          <p:cNvPr id="5" name="Notes Placeholder 4"/>
-          <p:cNvSpPr>
-            <a:spLocks noGrp="1"/>
-          </p:cNvSpPr>
-          <p:nvPr>
-            <p:ph type="body" sz="quarter" idx="3"/>
-          </p:nvPr>
-        </p:nvSpPr>
-        <p:spPr>
-          <a:xfrm>
-            <a:off x="685800" y="4400550"/>
-            <a:ext cx="5486400" cy="3600450"/>
-          </a:xfrm>
-          <a:prstGeom prst="rect">
-            <a:avLst/>
-          </a:prstGeom>
-        </p:spPr>
-        <p:txBody>
-          <a:bodyPr vert="horz" lIns="91440" tIns="45720" rIns="91440" bIns="45720" rtlCol="0"/>
-          <a:lstStyle/>
-          <a:p>
-            <a:pPr lvl="0"/>
-            <a:r>
-              <a:rPr lang="en-US"/>
-              <a:t>Click to edit Master text styles</a:t>
-            </a:r>
-          </a:p>
-          <a:p>
-            <a:pPr lvl="1"/>
-            <a:r>
-              <a:rPr lang="en-US"/>
-              <a:t>Second level</a:t>
-            </a:r>
-          </a:p>
-          <a:p>
-            <a:pPr lvl="2"/>
-            <a:r>
-              <a:rPr lang="en-US"/>
-              <a:t>Third level</a:t>
-            </a:r>
-          </a:p>
-          <a:p>
-            <a:pPr lvl="3"/>
-            <a:r>
-              <a:rPr lang="en-US"/>
-              <a:t>Fourth level</a:t>
-            </a:r>
-          </a:p>
-          <a:p>
-            <a:pPr lvl="4"/>
-            <a:r>
-              <a:rPr lang="en-US"/>
-              <a:t>Fifth level</a:t>
-            </a:r>
-          </a:p>
-        </p:txBody>
-      </p:sp>
-      <p:sp>
-        <p:nvSpPr>
-          <p:cNvPr id="6" name="Footer Placeholder 5"/>
-          <p:cNvSpPr>
-            <a:spLocks noGrp="1"/>
-          </p:cNvSpPr>
-          <p:nvPr>
-            <p:ph type="ftr" sz="quarter" idx="4"/>
-          </p:nvPr>
-        </p:nvSpPr>
-        <p:spPr>
-          <a:xfrm>
-            <a:off x="0" y="8685213"/>
-            <a:ext cx="2971800" cy="458787"/>
-          </a:xfrm>
-          <a:prstGeom prst="rect">
-            <a:avLst/>
-          </a:prstGeom>
-        </p:spPr>
-        <p:txBody>
-          <a:bodyPr vert="horz" lIns="91440" tIns="45720" rIns="91440" bIns="45720" rtlCol="0" anchor="b"/>
-          <a:lstStyle>
-            <a:lvl1pPr algn="l">
-              <a:defRPr sz="1200"/>
-            </a:lvl1pPr>
-          </a:lstStyle>
-          <a:p>
-            <a:endParaRPr lang="en-US"/>
-          </a:p>
-        </p:txBody>
-      </p:sp>
-      <p:sp>
-        <p:nvSpPr>
-          <p:cNvPr id="7" name="Slide Number Placeholder 6"/>
-          <p:cNvSpPr>
-            <a:spLocks noGrp="1"/>
-          </p:cNvSpPr>
-          <p:nvPr>
-            <p:ph type="sldNum" sz="quarter" idx="5"/>
-          </p:nvPr>
-        </p:nvSpPr>
-        <p:spPr>
-          <a:xfrm>
-            <a:off x="3884613" y="8685213"/>
-            <a:ext cx="2971800" cy="458787"/>
-          </a:xfrm>
-          <a:prstGeom prst="rect">
-            <a:avLst/>
-          </a:prstGeom>
-        </p:spPr>
-        <p:txBody>
-          <a:bodyPr vert="horz" lIns="91440" tIns="45720" rIns="91440" bIns="45720" rtlCol="0" anchor="b"/>
-          <a:lstStyle>
-            <a:lvl1pPr algn="r">
-              <a:defRPr sz="1200"/>
-            </a:lvl1pPr>
-          </a:lstStyle>
-          <a:p>
-            <a:fld id="{CE5E9CC1-C706-0F49-92D6-E571CC5EEA8F}" type="slidenum">
-              <a:rPr lang="en-US"/>
-              <a:t>‹#›</a:t>
-            </a:fld>
-            <a:endParaRPr lang="en-US"/>
-          </a:p>
-        </p:txBody>
-      </p:sp>
     </p:spTree>
     <p:extLst>
       <p:ext uri="{BB962C8B-B14F-4D97-AF65-F5344CB8AC3E}">
-        <p14:creationId xmlns:p14="http://schemas.microsoft.com/office/powerpoint/2010/main" val="1024086991"/>
+        <p14:creationId xmlns:p14="http://schemas.microsoft.com/office/powerpoint/2010/main" val="4238263441"/>
       </p:ext>
     </p:extLst>
   </p:cSld>
@@ -504,7 +285,6 @@
               <a:rPr lang="en-US" dirty="0"/>
               <a:t>Design draft for Fig. 1 (task F2). One screen of a generic video-sharing app; each numbered element maps to a layer of the ecosystem map (Table 1 order) with neuroscience examples. Final artwork: replace the mock-up with designer artwork, keep the layer colours (Okabe-Ito) consistent with Figs. 2 and 5, and avoid any real platform's name, logo, or look.</a:t>
             </a:r>
-            <a:endParaRPr lang="en-US" dirty="0"/>
           </a:p>
         </p:txBody>
       </p:sp>
@@ -577,6 +357,11 @@
 <file path=ppt/slideMasters/slideMaster1.xml><?xml version="1.0" encoding="utf-8"?>
 <p:sldMaster xmlns:a="http://schemas.openxmlformats.org/drawingml/2006/main" xmlns:r="http://schemas.openxmlformats.org/officeDocument/2006/relationships" xmlns:p="http://schemas.openxmlformats.org/presentationml/2006/main">
   <p:cSld>
+    <p:bg>
+      <p:bgRef idx="1001">
+        <a:schemeClr val="bg1"/>
+      </p:bgRef>
+    </p:bg>
     <p:spTree>
       <p:nvGrpSpPr>
         <p:cNvPr id="1" name=""/>
@@ -859,6 +644,7 @@
         <a:solidFill>
           <a:srgbClr val="FFFFFF"/>
         </a:solidFill>
+        <a:effectLst/>
       </p:bgPr>
     </p:bg>
     <p:spTree>
@@ -877,84 +663,6 @@
       </p:grpSpPr>
       <p:sp>
         <p:nvSpPr>
-          <p:cNvPr id="2" name="Title"/>
-          <p:cNvSpPr txBox="1"/>
-          <p:nvPr/>
-        </p:nvSpPr>
-        <p:spPr>
-          <a:xfrm>
-            <a:off x="457200" y="274320"/>
-            <a:ext cx="11247120" cy="457200"/>
-          </a:xfrm>
-          <a:prstGeom prst="rect">
-            <a:avLst/>
-          </a:prstGeom>
-          <a:noFill/>
-          <a:ln/>
-        </p:spPr>
-        <p:txBody>
-          <a:bodyPr wrap="square" lIns="0" tIns="0" rIns="0" bIns="0" rtlCol="0" anchor="ctr"/>
-          <a:lstStyle/>
-          <a:p>
-            <a:pPr indent="0" marL="0">
-              <a:buNone/>
-            </a:pPr>
-            <a:r>
-              <a:rPr lang="en-US" sz="2400" b="1" dirty="0">
-                <a:solidFill>
-                  <a:srgbClr val="1F2933"/>
-                </a:solidFill>
-                <a:latin typeface="Arial" pitchFamily="34" charset="0"/>
-                <a:ea typeface="Arial" pitchFamily="34" charset="-122"/>
-                <a:cs typeface="Arial" pitchFamily="34" charset="-120"/>
-              </a:rPr>
-              <a:t>The data standards ecosystem seen through a video-sharing app</a:t>
-            </a:r>
-            <a:endParaRPr lang="en-US" sz="2400" dirty="0"/>
-          </a:p>
-        </p:txBody>
-      </p:sp>
-      <p:sp>
-        <p:nvSpPr>
-          <p:cNvPr id="3" name="Subtitle"/>
-          <p:cNvSpPr txBox="1"/>
-          <p:nvPr/>
-        </p:nvSpPr>
-        <p:spPr>
-          <a:xfrm>
-            <a:off x="457200" y="713232"/>
-            <a:ext cx="11247120" cy="274320"/>
-          </a:xfrm>
-          <a:prstGeom prst="rect">
-            <a:avLst/>
-          </a:prstGeom>
-          <a:noFill/>
-          <a:ln/>
-        </p:spPr>
-        <p:txBody>
-          <a:bodyPr wrap="square" lIns="0" tIns="0" rIns="0" bIns="0" rtlCol="0" anchor="ctr"/>
-          <a:lstStyle/>
-          <a:p>
-            <a:pPr indent="0" marL="0">
-              <a:buNone/>
-            </a:pPr>
-            <a:r>
-              <a:rPr lang="en-US" sz="1100" i="1" dirty="0">
-                <a:solidFill>
-                  <a:srgbClr val="5B6770"/>
-                </a:solidFill>
-                <a:latin typeface="Arial" pitchFamily="34" charset="0"/>
-                <a:ea typeface="Arial" pitchFamily="34" charset="-122"/>
-                <a:cs typeface="Arial" pitchFamily="34" charset="-120"/>
-              </a:rPr>
-              <a:t>Fig. 1 design draft: generic app (no real platform name, logo, or look); numbers follow the layer order of Table 1</a:t>
-            </a:r>
-            <a:endParaRPr lang="en-US" sz="1100" dirty="0"/>
-          </a:p>
-        </p:txBody>
-      </p:sp>
-      <p:sp>
-        <p:nvSpPr>
           <p:cNvPr id="4" name="App window"/>
           <p:cNvSpPr/>
           <p:nvPr/>
@@ -979,13 +687,20 @@
             <a:prstDash val="solid"/>
           </a:ln>
           <a:effectLst>
-            <a:outerShdw sx="100000" sy="100000" kx="0" ky="0" algn="bl" rotWithShape="0" blurRad="101600" dist="25400" dir="5400000">
+            <a:outerShdw blurRad="101600" dist="25400" dir="5400000" algn="bl" rotWithShape="0">
               <a:srgbClr val="000000">
                 <a:alpha val="12000"/>
               </a:srgbClr>
             </a:outerShdw>
           </a:effectLst>
         </p:spPr>
+        <p:txBody>
+          <a:bodyPr/>
+          <a:lstStyle/>
+          <a:p>
+            <a:endParaRPr lang="en-US"/>
+          </a:p>
+        </p:txBody>
       </p:sp>
       <p:sp>
         <p:nvSpPr>
@@ -1013,6 +728,13 @@
             <a:prstDash val="solid"/>
           </a:ln>
         </p:spPr>
+        <p:txBody>
+          <a:bodyPr/>
+          <a:lstStyle/>
+          <a:p>
+            <a:endParaRPr lang="en-US"/>
+          </a:p>
+        </p:txBody>
       </p:sp>
       <p:sp>
         <p:nvSpPr>
@@ -1038,6 +760,13 @@
             <a:prstDash val="solid"/>
           </a:ln>
         </p:spPr>
+        <p:txBody>
+          <a:bodyPr/>
+          <a:lstStyle/>
+          <a:p>
+            <a:endParaRPr lang="en-US"/>
+          </a:p>
+        </p:txBody>
       </p:sp>
       <p:sp>
         <p:nvSpPr>
@@ -1065,6 +794,13 @@
             <a:prstDash val="solid"/>
           </a:ln>
         </p:spPr>
+        <p:txBody>
+          <a:bodyPr/>
+          <a:lstStyle/>
+          <a:p>
+            <a:endParaRPr lang="en-US"/>
+          </a:p>
+        </p:txBody>
       </p:sp>
       <p:sp>
         <p:nvSpPr>
@@ -1087,7 +823,7 @@
           <a:bodyPr wrap="square" lIns="0" tIns="0" rIns="0" bIns="0" rtlCol="0" anchor="ctr"/>
           <a:lstStyle/>
           <a:p>
-            <a:pPr indent="0" marL="0">
+            <a:pPr marL="0" indent="0">
               <a:buNone/>
             </a:pPr>
             <a:r>
@@ -1127,6 +863,13 @@
             <a:prstDash val="solid"/>
           </a:ln>
         </p:spPr>
+        <p:txBody>
+          <a:bodyPr/>
+          <a:lstStyle/>
+          <a:p>
+            <a:endParaRPr lang="en-US"/>
+          </a:p>
+        </p:txBody>
       </p:sp>
       <p:sp>
         <p:nvSpPr>
@@ -1152,6 +895,13 @@
             <a:prstDash val="solid"/>
           </a:ln>
         </p:spPr>
+        <p:txBody>
+          <a:bodyPr/>
+          <a:lstStyle/>
+          <a:p>
+            <a:endParaRPr lang="en-US"/>
+          </a:p>
+        </p:txBody>
       </p:sp>
       <p:sp>
         <p:nvSpPr>
@@ -1181,6 +931,13 @@
             <a:prstDash val="solid"/>
           </a:ln>
         </p:spPr>
+        <p:txBody>
+          <a:bodyPr/>
+          <a:lstStyle/>
+          <a:p>
+            <a:endParaRPr lang="en-US"/>
+          </a:p>
+        </p:txBody>
       </p:sp>
       <p:sp>
         <p:nvSpPr>
@@ -1203,7 +960,7 @@
           <a:bodyPr wrap="square" lIns="0" tIns="0" rIns="0" bIns="0" rtlCol="0" anchor="ctr"/>
           <a:lstStyle/>
           <a:p>
-            <a:pPr indent="0" marL="0">
+            <a:pPr marL="0" indent="0">
               <a:buNone/>
             </a:pPr>
             <a:r>
@@ -1247,6 +1004,13 @@
             <a:prstDash val="solid"/>
           </a:ln>
         </p:spPr>
+        <p:txBody>
+          <a:bodyPr/>
+          <a:lstStyle/>
+          <a:p>
+            <a:endParaRPr lang="en-US"/>
+          </a:p>
+        </p:txBody>
       </p:sp>
       <p:sp>
         <p:nvSpPr>
@@ -1269,7 +1033,7 @@
           <a:bodyPr wrap="square" lIns="0" tIns="0" rIns="0" bIns="0" rtlCol="0" anchor="ctr"/>
           <a:lstStyle/>
           <a:p>
-            <a:pPr algn="ctr" indent="0" marL="0">
+            <a:pPr marL="0" indent="0" algn="ctr">
               <a:buNone/>
             </a:pPr>
             <a:r>
@@ -1308,7 +1072,7 @@
           <a:bodyPr wrap="square" lIns="0" tIns="0" rIns="0" bIns="0" rtlCol="0" anchor="ctr"/>
           <a:lstStyle/>
           <a:p>
-            <a:pPr indent="0" marL="0">
+            <a:pPr marL="0" indent="0">
               <a:buNone/>
             </a:pPr>
             <a:r>
@@ -1350,6 +1114,13 @@
             <a:prstDash val="solid"/>
           </a:ln>
         </p:spPr>
+        <p:txBody>
+          <a:bodyPr/>
+          <a:lstStyle/>
+          <a:p>
+            <a:endParaRPr lang="en-US"/>
+          </a:p>
+        </p:txBody>
       </p:sp>
       <p:sp>
         <p:nvSpPr>
@@ -1375,6 +1146,13 @@
             <a:prstDash val="solid"/>
           </a:ln>
         </p:spPr>
+        <p:txBody>
+          <a:bodyPr/>
+          <a:lstStyle/>
+          <a:p>
+            <a:endParaRPr lang="en-US"/>
+          </a:p>
+        </p:txBody>
       </p:sp>
       <p:sp>
         <p:nvSpPr>
@@ -1397,7 +1175,7 @@
           <a:bodyPr wrap="square" lIns="0" tIns="0" rIns="0" bIns="0" rtlCol="0" anchor="ctr"/>
           <a:lstStyle/>
           <a:p>
-            <a:pPr indent="0" marL="0">
+            <a:pPr marL="0" indent="0">
               <a:buNone/>
             </a:pPr>
             <a:r>
@@ -1439,6 +1217,13 @@
             <a:prstDash val="solid"/>
           </a:ln>
         </p:spPr>
+        <p:txBody>
+          <a:bodyPr/>
+          <a:lstStyle/>
+          <a:p>
+            <a:endParaRPr lang="en-US"/>
+          </a:p>
+        </p:txBody>
       </p:sp>
       <p:sp>
         <p:nvSpPr>
@@ -1464,6 +1249,13 @@
             <a:prstDash val="solid"/>
           </a:ln>
         </p:spPr>
+        <p:txBody>
+          <a:bodyPr/>
+          <a:lstStyle/>
+          <a:p>
+            <a:endParaRPr lang="en-US"/>
+          </a:p>
+        </p:txBody>
       </p:sp>
       <p:sp>
         <p:nvSpPr>
@@ -1486,7 +1278,7 @@
           <a:bodyPr wrap="square" lIns="0" tIns="0" rIns="0" bIns="0" rtlCol="0" anchor="ctr"/>
           <a:lstStyle/>
           <a:p>
-            <a:pPr indent="0" marL="0">
+            <a:pPr marL="0" indent="0">
               <a:buNone/>
             </a:pPr>
             <a:r>
@@ -1528,6 +1320,13 @@
             <a:prstDash val="solid"/>
           </a:ln>
         </p:spPr>
+        <p:txBody>
+          <a:bodyPr/>
+          <a:lstStyle/>
+          <a:p>
+            <a:endParaRPr lang="en-US"/>
+          </a:p>
+        </p:txBody>
       </p:sp>
       <p:sp>
         <p:nvSpPr>
@@ -1553,6 +1352,13 @@
             <a:prstDash val="solid"/>
           </a:ln>
         </p:spPr>
+        <p:txBody>
+          <a:bodyPr/>
+          <a:lstStyle/>
+          <a:p>
+            <a:endParaRPr lang="en-US"/>
+          </a:p>
+        </p:txBody>
       </p:sp>
       <p:sp>
         <p:nvSpPr>
@@ -1576,6 +1382,13 @@
             <a:prstDash val="solid"/>
           </a:ln>
         </p:spPr>
+        <p:txBody>
+          <a:bodyPr/>
+          <a:lstStyle/>
+          <a:p>
+            <a:endParaRPr lang="en-US"/>
+          </a:p>
+        </p:txBody>
       </p:sp>
       <p:sp>
         <p:nvSpPr>
@@ -1598,7 +1411,7 @@
           <a:bodyPr wrap="square" lIns="0" tIns="0" rIns="0" bIns="0" rtlCol="0" anchor="ctr"/>
           <a:lstStyle/>
           <a:p>
-            <a:pPr indent="0" marL="0">
+            <a:pPr marL="0" indent="0">
               <a:buNone/>
             </a:pPr>
             <a:r>
@@ -1642,6 +1455,13 @@
             <a:prstDash val="solid"/>
           </a:ln>
         </p:spPr>
+        <p:txBody>
+          <a:bodyPr/>
+          <a:lstStyle/>
+          <a:p>
+            <a:endParaRPr lang="en-US"/>
+          </a:p>
+        </p:txBody>
       </p:sp>
       <p:sp>
         <p:nvSpPr>
@@ -1664,7 +1484,7 @@
           <a:bodyPr wrap="square" lIns="0" tIns="0" rIns="0" bIns="0" rtlCol="0" anchor="ctr"/>
           <a:lstStyle/>
           <a:p>
-            <a:pPr algn="ctr" indent="0" marL="0">
+            <a:pPr marL="0" indent="0" algn="ctr">
               <a:buNone/>
             </a:pPr>
             <a:r>
@@ -1708,6 +1528,13 @@
             <a:prstDash val="solid"/>
           </a:ln>
         </p:spPr>
+        <p:txBody>
+          <a:bodyPr/>
+          <a:lstStyle/>
+          <a:p>
+            <a:endParaRPr lang="en-US"/>
+          </a:p>
+        </p:txBody>
       </p:sp>
       <p:sp>
         <p:nvSpPr>
@@ -1730,7 +1557,7 @@
           <a:bodyPr wrap="square" lIns="0" tIns="0" rIns="0" bIns="0" rtlCol="0" anchor="ctr"/>
           <a:lstStyle/>
           <a:p>
-            <a:pPr algn="ctr" indent="0" marL="0">
+            <a:pPr marL="0" indent="0" algn="ctr">
               <a:buNone/>
             </a:pPr>
             <a:r>
@@ -1774,6 +1601,13 @@
             <a:prstDash val="solid"/>
           </a:ln>
         </p:spPr>
+        <p:txBody>
+          <a:bodyPr/>
+          <a:lstStyle/>
+          <a:p>
+            <a:endParaRPr lang="en-US"/>
+          </a:p>
+        </p:txBody>
       </p:sp>
       <p:sp>
         <p:nvSpPr>
@@ -1796,7 +1630,7 @@
           <a:bodyPr wrap="square" lIns="0" tIns="0" rIns="0" bIns="0" rtlCol="0" anchor="ctr"/>
           <a:lstStyle/>
           <a:p>
-            <a:pPr algn="ctr" indent="0" marL="0">
+            <a:pPr marL="0" indent="0" algn="ctr">
               <a:buNone/>
             </a:pPr>
             <a:r>
@@ -1840,6 +1674,13 @@
             <a:prstDash val="solid"/>
           </a:ln>
         </p:spPr>
+        <p:txBody>
+          <a:bodyPr/>
+          <a:lstStyle/>
+          <a:p>
+            <a:endParaRPr lang="en-US"/>
+          </a:p>
+        </p:txBody>
       </p:sp>
       <p:sp>
         <p:nvSpPr>
@@ -1862,7 +1703,7 @@
           <a:bodyPr wrap="square" lIns="0" tIns="0" rIns="0" bIns="0" rtlCol="0" anchor="ctr"/>
           <a:lstStyle/>
           <a:p>
-            <a:pPr algn="ctr" indent="0" marL="0">
+            <a:pPr marL="0" indent="0" algn="ctr">
               <a:buNone/>
             </a:pPr>
             <a:r>
@@ -1906,6 +1747,13 @@
             <a:prstDash val="solid"/>
           </a:ln>
         </p:spPr>
+        <p:txBody>
+          <a:bodyPr/>
+          <a:lstStyle/>
+          <a:p>
+            <a:endParaRPr lang="en-US"/>
+          </a:p>
+        </p:txBody>
       </p:sp>
       <p:sp>
         <p:nvSpPr>
@@ -1928,7 +1776,7 @@
           <a:bodyPr wrap="square" lIns="0" tIns="0" rIns="0" bIns="0" rtlCol="0" anchor="ctr"/>
           <a:lstStyle/>
           <a:p>
-            <a:pPr indent="0" marL="0">
+            <a:pPr marL="0" indent="0">
               <a:buNone/>
             </a:pPr>
             <a:r>
@@ -1967,7 +1815,7 @@
           <a:bodyPr wrap="square" lIns="0" tIns="0" rIns="0" bIns="0" rtlCol="0" anchor="ctr"/>
           <a:lstStyle/>
           <a:p>
-            <a:pPr indent="0" marL="0">
+            <a:pPr marL="0" indent="0">
               <a:buNone/>
             </a:pPr>
             <a:r>
@@ -2009,6 +1857,13 @@
             <a:prstDash val="solid"/>
           </a:ln>
         </p:spPr>
+        <p:txBody>
+          <a:bodyPr/>
+          <a:lstStyle/>
+          <a:p>
+            <a:endParaRPr lang="en-US"/>
+          </a:p>
+        </p:txBody>
       </p:sp>
       <p:sp>
         <p:nvSpPr>
@@ -2031,7 +1886,7 @@
           <a:bodyPr wrap="square" lIns="0" tIns="0" rIns="0" bIns="0" rtlCol="0" anchor="ctr"/>
           <a:lstStyle/>
           <a:p>
-            <a:pPr indent="0" marL="0">
+            <a:pPr marL="0" indent="0">
               <a:buNone/>
             </a:pPr>
             <a:r>
@@ -2070,7 +1925,7 @@
           <a:bodyPr wrap="square" lIns="0" tIns="0" rIns="0" bIns="0" rtlCol="0" anchor="ctr"/>
           <a:lstStyle/>
           <a:p>
-            <a:pPr indent="0" marL="0">
+            <a:pPr marL="0" indent="0">
               <a:buNone/>
             </a:pPr>
             <a:r>
@@ -2114,6 +1969,13 @@
             <a:prstDash val="dash"/>
           </a:ln>
         </p:spPr>
+        <p:txBody>
+          <a:bodyPr/>
+          <a:lstStyle/>
+          <a:p>
+            <a:endParaRPr lang="en-US"/>
+          </a:p>
+        </p:txBody>
       </p:sp>
       <p:sp>
         <p:nvSpPr>
@@ -2136,7 +1998,7 @@
           <a:bodyPr wrap="square" lIns="0" tIns="0" rIns="0" bIns="0" rtlCol="0" anchor="ctr"/>
           <a:lstStyle/>
           <a:p>
-            <a:pPr indent="0" marL="0">
+            <a:pPr marL="0" indent="0">
               <a:buNone/>
             </a:pPr>
             <a:r>
@@ -2178,6 +2040,13 @@
             <a:prstDash val="solid"/>
           </a:ln>
         </p:spPr>
+        <p:txBody>
+          <a:bodyPr/>
+          <a:lstStyle/>
+          <a:p>
+            <a:endParaRPr lang="en-US"/>
+          </a:p>
+        </p:txBody>
       </p:sp>
       <p:sp>
         <p:nvSpPr>
@@ -2200,7 +2069,7 @@
           <a:bodyPr wrap="square" lIns="0" tIns="0" rIns="0" bIns="0" rtlCol="0" anchor="ctr"/>
           <a:lstStyle/>
           <a:p>
-            <a:pPr indent="0" marL="0">
+            <a:pPr marL="0" indent="0">
               <a:buNone/>
             </a:pPr>
             <a:r>
@@ -2242,6 +2111,13 @@
             <a:prstDash val="solid"/>
           </a:ln>
         </p:spPr>
+        <p:txBody>
+          <a:bodyPr/>
+          <a:lstStyle/>
+          <a:p>
+            <a:endParaRPr lang="en-US"/>
+          </a:p>
+        </p:txBody>
       </p:sp>
       <p:sp>
         <p:nvSpPr>
@@ -2264,7 +2140,7 @@
           <a:bodyPr wrap="square" lIns="0" tIns="0" rIns="0" bIns="0" rtlCol="0" anchor="ctr"/>
           <a:lstStyle/>
           <a:p>
-            <a:pPr indent="0" marL="0">
+            <a:pPr marL="0" indent="0">
               <a:buNone/>
             </a:pPr>
             <a:r>
@@ -2306,6 +2182,13 @@
             <a:prstDash val="solid"/>
           </a:ln>
         </p:spPr>
+        <p:txBody>
+          <a:bodyPr/>
+          <a:lstStyle/>
+          <a:p>
+            <a:endParaRPr lang="en-US"/>
+          </a:p>
+        </p:txBody>
       </p:sp>
       <p:sp>
         <p:nvSpPr>
@@ -2328,7 +2211,7 @@
           <a:bodyPr wrap="square" lIns="0" tIns="0" rIns="0" bIns="0" rtlCol="0" anchor="ctr"/>
           <a:lstStyle/>
           <a:p>
-            <a:pPr indent="0" marL="0">
+            <a:pPr marL="0" indent="0">
               <a:buNone/>
             </a:pPr>
             <a:r>
@@ -2367,7 +2250,7 @@
           <a:bodyPr wrap="square" lIns="0" tIns="0" rIns="0" bIns="0" rtlCol="0" anchor="ctr"/>
           <a:lstStyle/>
           <a:p>
-            <a:pPr indent="0" marL="0">
+            <a:pPr marL="0" indent="0">
               <a:buNone/>
             </a:pPr>
             <a:r>
@@ -2413,6 +2296,13 @@
             <a:prstDash val="solid"/>
           </a:ln>
         </p:spPr>
+        <p:txBody>
+          <a:bodyPr/>
+          <a:lstStyle/>
+          <a:p>
+            <a:endParaRPr lang="en-US"/>
+          </a:p>
+        </p:txBody>
       </p:sp>
       <p:sp>
         <p:nvSpPr>
@@ -2438,6 +2328,13 @@
             <a:prstDash val="solid"/>
           </a:ln>
         </p:spPr>
+        <p:txBody>
+          <a:bodyPr/>
+          <a:lstStyle/>
+          <a:p>
+            <a:endParaRPr lang="en-US"/>
+          </a:p>
+        </p:txBody>
       </p:sp>
       <p:sp>
         <p:nvSpPr>
@@ -2460,7 +2357,7 @@
           <a:bodyPr wrap="square" lIns="0" tIns="0" rIns="0" bIns="0" rtlCol="0" anchor="ctr"/>
           <a:lstStyle/>
           <a:p>
-            <a:pPr algn="ctr" indent="0" marL="0">
+            <a:pPr marL="0" indent="0" algn="ctr">
               <a:buNone/>
             </a:pPr>
             <a:r>
@@ -2499,7 +2396,7 @@
           <a:bodyPr wrap="square" lIns="0" tIns="0" rIns="0" bIns="0" rtlCol="0" anchor="ctr"/>
           <a:lstStyle/>
           <a:p>
-            <a:pPr indent="0" marL="0">
+            <a:pPr marL="0" indent="0">
               <a:buNone/>
             </a:pPr>
             <a:r>
@@ -2538,7 +2435,7 @@
           <a:bodyPr wrap="square" lIns="0" tIns="0" rIns="0" bIns="0" rtlCol="0" anchor="t"/>
           <a:lstStyle/>
           <a:p>
-            <a:pPr indent="0" marL="0">
+            <a:pPr marL="0" indent="0">
               <a:buNone/>
             </a:pPr>
             <a:r>
@@ -2577,7 +2474,7 @@
           <a:bodyPr wrap="square" lIns="0" tIns="0" rIns="0" bIns="0" rtlCol="0" anchor="ctr"/>
           <a:lstStyle/>
           <a:p>
-            <a:pPr indent="0" marL="0">
+            <a:pPr marL="0" indent="0">
               <a:buNone/>
             </a:pPr>
             <a:r>
@@ -2591,9 +2488,6 @@
               </a:rPr>
               <a:t>Neuroscience: </a:t>
             </a:r>
-            <a:pPr indent="0" marL="0">
-              <a:buNone/>
-            </a:pPr>
             <a:r>
               <a:rPr lang="en-US" sz="1150" b="1" dirty="0">
                 <a:solidFill>
@@ -2631,6 +2525,13 @@
             <a:prstDash val="solid"/>
           </a:ln>
         </p:spPr>
+        <p:txBody>
+          <a:bodyPr/>
+          <a:lstStyle/>
+          <a:p>
+            <a:endParaRPr lang="en-US"/>
+          </a:p>
+        </p:txBody>
       </p:sp>
       <p:sp>
         <p:nvSpPr>
@@ -2656,6 +2557,13 @@
             <a:prstDash val="solid"/>
           </a:ln>
         </p:spPr>
+        <p:txBody>
+          <a:bodyPr/>
+          <a:lstStyle/>
+          <a:p>
+            <a:endParaRPr lang="en-US"/>
+          </a:p>
+        </p:txBody>
       </p:sp>
       <p:sp>
         <p:nvSpPr>
@@ -2678,7 +2586,7 @@
           <a:bodyPr wrap="square" lIns="0" tIns="0" rIns="0" bIns="0" rtlCol="0" anchor="ctr"/>
           <a:lstStyle/>
           <a:p>
-            <a:pPr algn="ctr" indent="0" marL="0">
+            <a:pPr marL="0" indent="0" algn="ctr">
               <a:buNone/>
             </a:pPr>
             <a:r>
@@ -2724,6 +2632,13 @@
             <a:prstDash val="solid"/>
           </a:ln>
         </p:spPr>
+        <p:txBody>
+          <a:bodyPr/>
+          <a:lstStyle/>
+          <a:p>
+            <a:endParaRPr lang="en-US"/>
+          </a:p>
+        </p:txBody>
       </p:sp>
       <p:sp>
         <p:nvSpPr>
@@ -2749,6 +2664,13 @@
             <a:prstDash val="solid"/>
           </a:ln>
         </p:spPr>
+        <p:txBody>
+          <a:bodyPr/>
+          <a:lstStyle/>
+          <a:p>
+            <a:endParaRPr lang="en-US"/>
+          </a:p>
+        </p:txBody>
       </p:sp>
       <p:sp>
         <p:nvSpPr>
@@ -2771,7 +2693,7 @@
           <a:bodyPr wrap="square" lIns="0" tIns="0" rIns="0" bIns="0" rtlCol="0" anchor="ctr"/>
           <a:lstStyle/>
           <a:p>
-            <a:pPr algn="ctr" indent="0" marL="0">
+            <a:pPr marL="0" indent="0" algn="ctr">
               <a:buNone/>
             </a:pPr>
             <a:r>
@@ -2810,7 +2732,7 @@
           <a:bodyPr wrap="square" lIns="0" tIns="0" rIns="0" bIns="0" rtlCol="0" anchor="ctr"/>
           <a:lstStyle/>
           <a:p>
-            <a:pPr indent="0" marL="0">
+            <a:pPr marL="0" indent="0">
               <a:buNone/>
             </a:pPr>
             <a:r>
@@ -2849,7 +2771,7 @@
           <a:bodyPr wrap="square" lIns="0" tIns="0" rIns="0" bIns="0" rtlCol="0" anchor="t"/>
           <a:lstStyle/>
           <a:p>
-            <a:pPr indent="0" marL="0">
+            <a:pPr marL="0" indent="0">
               <a:buNone/>
             </a:pPr>
             <a:r>
@@ -2861,7 +2783,7 @@
                 <a:ea typeface="Arial" pitchFamily="34" charset="-122"/>
                 <a:cs typeface="Arial" pitchFamily="34" charset="-120"/>
               </a:rPr>
-              <a:t>A series with numbered episodes (S1E1, S1E2)</a:t>
+              <a:t>Structured playlists organize collections of videos into series with numbered episodes</a:t>
             </a:r>
             <a:endParaRPr lang="en-US" sz="1100" dirty="0"/>
           </a:p>
@@ -2888,7 +2810,7 @@
           <a:bodyPr wrap="square" lIns="0" tIns="0" rIns="0" bIns="0" rtlCol="0" anchor="ctr"/>
           <a:lstStyle/>
           <a:p>
-            <a:pPr indent="0" marL="0">
+            <a:pPr marL="0" indent="0">
               <a:buNone/>
             </a:pPr>
             <a:r>
@@ -2902,9 +2824,6 @@
               </a:rPr>
               <a:t>Neuroscience: </a:t>
             </a:r>
-            <a:pPr indent="0" marL="0">
-              <a:buNone/>
-            </a:pPr>
             <a:r>
               <a:rPr lang="en-US" sz="1150" b="1" dirty="0">
                 <a:solidFill>
@@ -2942,6 +2861,13 @@
             <a:prstDash val="solid"/>
           </a:ln>
         </p:spPr>
+        <p:txBody>
+          <a:bodyPr/>
+          <a:lstStyle/>
+          <a:p>
+            <a:endParaRPr lang="en-US"/>
+          </a:p>
+        </p:txBody>
       </p:sp>
       <p:sp>
         <p:nvSpPr>
@@ -2967,6 +2893,13 @@
             <a:prstDash val="solid"/>
           </a:ln>
         </p:spPr>
+        <p:txBody>
+          <a:bodyPr/>
+          <a:lstStyle/>
+          <a:p>
+            <a:endParaRPr lang="en-US"/>
+          </a:p>
+        </p:txBody>
       </p:sp>
       <p:sp>
         <p:nvSpPr>
@@ -2989,7 +2922,7 @@
           <a:bodyPr wrap="square" lIns="0" tIns="0" rIns="0" bIns="0" rtlCol="0" anchor="ctr"/>
           <a:lstStyle/>
           <a:p>
-            <a:pPr algn="ctr" indent="0" marL="0">
+            <a:pPr marL="0" indent="0" algn="ctr">
               <a:buNone/>
             </a:pPr>
             <a:r>
@@ -3035,6 +2968,13 @@
             <a:prstDash val="solid"/>
           </a:ln>
         </p:spPr>
+        <p:txBody>
+          <a:bodyPr/>
+          <a:lstStyle/>
+          <a:p>
+            <a:endParaRPr lang="en-US"/>
+          </a:p>
+        </p:txBody>
       </p:sp>
       <p:sp>
         <p:nvSpPr>
@@ -3060,6 +3000,13 @@
             <a:prstDash val="solid"/>
           </a:ln>
         </p:spPr>
+        <p:txBody>
+          <a:bodyPr/>
+          <a:lstStyle/>
+          <a:p>
+            <a:endParaRPr lang="en-US"/>
+          </a:p>
+        </p:txBody>
       </p:sp>
       <p:sp>
         <p:nvSpPr>
@@ -3082,7 +3029,7 @@
           <a:bodyPr wrap="square" lIns="0" tIns="0" rIns="0" bIns="0" rtlCol="0" anchor="ctr"/>
           <a:lstStyle/>
           <a:p>
-            <a:pPr algn="ctr" indent="0" marL="0">
+            <a:pPr marL="0" indent="0" algn="ctr">
               <a:buNone/>
             </a:pPr>
             <a:r>
@@ -3121,7 +3068,7 @@
           <a:bodyPr wrap="square" lIns="0" tIns="0" rIns="0" bIns="0" rtlCol="0" anchor="ctr"/>
           <a:lstStyle/>
           <a:p>
-            <a:pPr indent="0" marL="0">
+            <a:pPr marL="0" indent="0">
               <a:buNone/>
             </a:pPr>
             <a:r>
@@ -3160,7 +3107,7 @@
           <a:bodyPr wrap="square" lIns="0" tIns="0" rIns="0" bIns="0" rtlCol="0" anchor="t"/>
           <a:lstStyle/>
           <a:p>
-            <a:pPr indent="0" marL="0">
+            <a:pPr marL="0" indent="0">
               <a:buNone/>
             </a:pPr>
             <a:r>
@@ -3172,7 +3119,7 @@
                 <a:ea typeface="Arial" pitchFamily="34" charset="-122"/>
                 <a:cs typeface="Arial" pitchFamily="34" charset="-120"/>
               </a:rPr>
-              <a:t>The MP4 file keeps video, audio, and subtitles in sync</a:t>
+              <a:t>The MP4 file organizes synchronized video, audio, and subtitles data in a single file</a:t>
             </a:r>
             <a:endParaRPr lang="en-US" sz="1100" dirty="0"/>
           </a:p>
@@ -3199,7 +3146,7 @@
           <a:bodyPr wrap="square" lIns="0" tIns="0" rIns="0" bIns="0" rtlCol="0" anchor="ctr"/>
           <a:lstStyle/>
           <a:p>
-            <a:pPr indent="0" marL="0">
+            <a:pPr marL="0" indent="0">
               <a:buNone/>
             </a:pPr>
             <a:r>
@@ -3213,9 +3160,6 @@
               </a:rPr>
               <a:t>Neuroscience: </a:t>
             </a:r>
-            <a:pPr indent="0" marL="0">
-              <a:buNone/>
-            </a:pPr>
             <a:r>
               <a:rPr lang="en-US" sz="1150" b="1" dirty="0">
                 <a:solidFill>
@@ -3225,7 +3169,7 @@
                 <a:ea typeface="Arial" pitchFamily="34" charset="-122"/>
                 <a:cs typeface="Arial" pitchFamily="34" charset="-120"/>
               </a:rPr>
-              <a:t>NWB, OME-Zarr</a:t>
+              <a:t>NWB, OME-Zarr, NIX</a:t>
             </a:r>
             <a:endParaRPr lang="en-US" sz="1150" dirty="0"/>
           </a:p>
@@ -3253,6 +3197,13 @@
             <a:prstDash val="solid"/>
           </a:ln>
         </p:spPr>
+        <p:txBody>
+          <a:bodyPr/>
+          <a:lstStyle/>
+          <a:p>
+            <a:endParaRPr lang="en-US"/>
+          </a:p>
+        </p:txBody>
       </p:sp>
       <p:sp>
         <p:nvSpPr>
@@ -3278,6 +3229,13 @@
             <a:prstDash val="solid"/>
           </a:ln>
         </p:spPr>
+        <p:txBody>
+          <a:bodyPr/>
+          <a:lstStyle/>
+          <a:p>
+            <a:endParaRPr lang="en-US"/>
+          </a:p>
+        </p:txBody>
       </p:sp>
       <p:sp>
         <p:nvSpPr>
@@ -3300,7 +3258,7 @@
           <a:bodyPr wrap="square" lIns="0" tIns="0" rIns="0" bIns="0" rtlCol="0" anchor="ctr"/>
           <a:lstStyle/>
           <a:p>
-            <a:pPr algn="ctr" indent="0" marL="0">
+            <a:pPr marL="0" indent="0" algn="ctr">
               <a:buNone/>
             </a:pPr>
             <a:r>
@@ -3346,6 +3304,13 @@
             <a:prstDash val="solid"/>
           </a:ln>
         </p:spPr>
+        <p:txBody>
+          <a:bodyPr/>
+          <a:lstStyle/>
+          <a:p>
+            <a:endParaRPr lang="en-US"/>
+          </a:p>
+        </p:txBody>
       </p:sp>
       <p:sp>
         <p:nvSpPr>
@@ -3371,6 +3336,13 @@
             <a:prstDash val="solid"/>
           </a:ln>
         </p:spPr>
+        <p:txBody>
+          <a:bodyPr/>
+          <a:lstStyle/>
+          <a:p>
+            <a:endParaRPr lang="en-US"/>
+          </a:p>
+        </p:txBody>
       </p:sp>
       <p:sp>
         <p:nvSpPr>
@@ -3393,7 +3365,7 @@
           <a:bodyPr wrap="square" lIns="0" tIns="0" rIns="0" bIns="0" rtlCol="0" anchor="ctr"/>
           <a:lstStyle/>
           <a:p>
-            <a:pPr algn="ctr" indent="0" marL="0">
+            <a:pPr marL="0" indent="0" algn="ctr">
               <a:buNone/>
             </a:pPr>
             <a:r>
@@ -3432,7 +3404,7 @@
           <a:bodyPr wrap="square" lIns="0" tIns="0" rIns="0" bIns="0" rtlCol="0" anchor="ctr"/>
           <a:lstStyle/>
           <a:p>
-            <a:pPr indent="0" marL="0">
+            <a:pPr marL="0" indent="0">
               <a:buNone/>
             </a:pPr>
             <a:r>
@@ -3471,7 +3443,7 @@
           <a:bodyPr wrap="square" lIns="0" tIns="0" rIns="0" bIns="0" rtlCol="0" anchor="t"/>
           <a:lstStyle/>
           <a:p>
-            <a:pPr indent="0" marL="0">
+            <a:pPr marL="0" indent="0">
               <a:buNone/>
             </a:pPr>
             <a:r>
@@ -3483,7 +3455,7 @@
                 <a:ea typeface="Arial" pitchFamily="34" charset="-122"/>
                 <a:cs typeface="Arial" pitchFamily="34" charset="-120"/>
               </a:rPr>
-              <a:t>Categories and hashtags give content a shared meaning</a:t>
+              <a:t>Standardized categories and hashtags give content a shared meaning</a:t>
             </a:r>
             <a:endParaRPr lang="en-US" sz="1100" dirty="0"/>
           </a:p>
@@ -3510,7 +3482,7 @@
           <a:bodyPr wrap="square" lIns="0" tIns="0" rIns="0" bIns="0" rtlCol="0" anchor="ctr"/>
           <a:lstStyle/>
           <a:p>
-            <a:pPr indent="0" marL="0">
+            <a:pPr marL="0" indent="0">
               <a:buNone/>
             </a:pPr>
             <a:r>
@@ -3524,9 +3496,6 @@
               </a:rPr>
               <a:t>Neuroscience: </a:t>
             </a:r>
-            <a:pPr indent="0" marL="0">
-              <a:buNone/>
-            </a:pPr>
             <a:r>
               <a:rPr lang="en-US" sz="1150" b="1" dirty="0">
                 <a:solidFill>
@@ -3564,6 +3533,13 @@
             <a:prstDash val="solid"/>
           </a:ln>
         </p:spPr>
+        <p:txBody>
+          <a:bodyPr/>
+          <a:lstStyle/>
+          <a:p>
+            <a:endParaRPr lang="en-US"/>
+          </a:p>
+        </p:txBody>
       </p:sp>
       <p:sp>
         <p:nvSpPr>
@@ -3589,6 +3565,13 @@
             <a:prstDash val="solid"/>
           </a:ln>
         </p:spPr>
+        <p:txBody>
+          <a:bodyPr/>
+          <a:lstStyle/>
+          <a:p>
+            <a:endParaRPr lang="en-US"/>
+          </a:p>
+        </p:txBody>
       </p:sp>
       <p:sp>
         <p:nvSpPr>
@@ -3611,7 +3594,7 @@
           <a:bodyPr wrap="square" lIns="0" tIns="0" rIns="0" bIns="0" rtlCol="0" anchor="ctr"/>
           <a:lstStyle/>
           <a:p>
-            <a:pPr algn="ctr" indent="0" marL="0">
+            <a:pPr marL="0" indent="0" algn="ctr">
               <a:buNone/>
             </a:pPr>
             <a:r>
@@ -3657,6 +3640,13 @@
             <a:prstDash val="solid"/>
           </a:ln>
         </p:spPr>
+        <p:txBody>
+          <a:bodyPr/>
+          <a:lstStyle/>
+          <a:p>
+            <a:endParaRPr lang="en-US"/>
+          </a:p>
+        </p:txBody>
       </p:sp>
       <p:sp>
         <p:nvSpPr>
@@ -3682,6 +3672,13 @@
             <a:prstDash val="solid"/>
           </a:ln>
         </p:spPr>
+        <p:txBody>
+          <a:bodyPr/>
+          <a:lstStyle/>
+          <a:p>
+            <a:endParaRPr lang="en-US"/>
+          </a:p>
+        </p:txBody>
       </p:sp>
       <p:sp>
         <p:nvSpPr>
@@ -3704,7 +3701,7 @@
           <a:bodyPr wrap="square" lIns="0" tIns="0" rIns="0" bIns="0" rtlCol="0" anchor="ctr"/>
           <a:lstStyle/>
           <a:p>
-            <a:pPr algn="ctr" indent="0" marL="0">
+            <a:pPr marL="0" indent="0" algn="ctr">
               <a:buNone/>
             </a:pPr>
             <a:r>
@@ -3743,7 +3740,7 @@
           <a:bodyPr wrap="square" lIns="0" tIns="0" rIns="0" bIns="0" rtlCol="0" anchor="ctr"/>
           <a:lstStyle/>
           <a:p>
-            <a:pPr indent="0" marL="0">
+            <a:pPr marL="0" indent="0">
               <a:buNone/>
             </a:pPr>
             <a:r>
@@ -3782,7 +3779,7 @@
           <a:bodyPr wrap="square" lIns="0" tIns="0" rIns="0" bIns="0" rtlCol="0" anchor="t"/>
           <a:lstStyle/>
           <a:p>
-            <a:pPr indent="0" marL="0">
+            <a:pPr marL="0" indent="0">
               <a:buNone/>
             </a:pPr>
             <a:r>
@@ -3821,7 +3818,7 @@
           <a:bodyPr wrap="square" lIns="0" tIns="0" rIns="0" bIns="0" rtlCol="0" anchor="ctr"/>
           <a:lstStyle/>
           <a:p>
-            <a:pPr indent="0" marL="0">
+            <a:pPr marL="0" indent="0">
               <a:buNone/>
             </a:pPr>
             <a:r>
@@ -3835,9 +3832,6 @@
               </a:rPr>
               <a:t>Neuroscience: </a:t>
             </a:r>
-            <a:pPr indent="0" marL="0">
-              <a:buNone/>
-            </a:pPr>
             <a:r>
               <a:rPr lang="en-US" sz="1150" b="1" dirty="0">
                 <a:solidFill>
@@ -3875,6 +3869,13 @@
             <a:prstDash val="solid"/>
           </a:ln>
         </p:spPr>
+        <p:txBody>
+          <a:bodyPr/>
+          <a:lstStyle/>
+          <a:p>
+            <a:endParaRPr lang="en-US"/>
+          </a:p>
+        </p:txBody>
       </p:sp>
       <p:sp>
         <p:nvSpPr>
@@ -3900,6 +3901,13 @@
             <a:prstDash val="solid"/>
           </a:ln>
         </p:spPr>
+        <p:txBody>
+          <a:bodyPr/>
+          <a:lstStyle/>
+          <a:p>
+            <a:endParaRPr lang="en-US"/>
+          </a:p>
+        </p:txBody>
       </p:sp>
       <p:sp>
         <p:nvSpPr>
@@ -3922,7 +3930,7 @@
           <a:bodyPr wrap="square" lIns="0" tIns="0" rIns="0" bIns="0" rtlCol="0" anchor="ctr"/>
           <a:lstStyle/>
           <a:p>
-            <a:pPr algn="ctr" indent="0" marL="0">
+            <a:pPr marL="0" indent="0" algn="ctr">
               <a:buNone/>
             </a:pPr>
             <a:r>
@@ -3968,6 +3976,13 @@
             <a:prstDash val="solid"/>
           </a:ln>
         </p:spPr>
+        <p:txBody>
+          <a:bodyPr/>
+          <a:lstStyle/>
+          <a:p>
+            <a:endParaRPr lang="en-US"/>
+          </a:p>
+        </p:txBody>
       </p:sp>
       <p:sp>
         <p:nvSpPr>
@@ -3993,6 +4008,13 @@
             <a:prstDash val="solid"/>
           </a:ln>
         </p:spPr>
+        <p:txBody>
+          <a:bodyPr/>
+          <a:lstStyle/>
+          <a:p>
+            <a:endParaRPr lang="en-US"/>
+          </a:p>
+        </p:txBody>
       </p:sp>
       <p:sp>
         <p:nvSpPr>
@@ -4015,7 +4037,7 @@
           <a:bodyPr wrap="square" lIns="0" tIns="0" rIns="0" bIns="0" rtlCol="0" anchor="ctr"/>
           <a:lstStyle/>
           <a:p>
-            <a:pPr algn="ctr" indent="0" marL="0">
+            <a:pPr marL="0" indent="0" algn="ctr">
               <a:buNone/>
             </a:pPr>
             <a:r>
@@ -4054,7 +4076,7 @@
           <a:bodyPr wrap="square" lIns="0" tIns="0" rIns="0" bIns="0" rtlCol="0" anchor="ctr"/>
           <a:lstStyle/>
           <a:p>
-            <a:pPr indent="0" marL="0">
+            <a:pPr marL="0" indent="0">
               <a:buNone/>
             </a:pPr>
             <a:r>
@@ -4093,7 +4115,7 @@
           <a:bodyPr wrap="square" lIns="0" tIns="0" rIns="0" bIns="0" rtlCol="0" anchor="t"/>
           <a:lstStyle/>
           <a:p>
-            <a:pPr indent="0" marL="0">
+            <a:pPr marL="0" indent="0">
               <a:buNone/>
             </a:pPr>
             <a:r>
@@ -4105,7 +4127,7 @@
                 <a:ea typeface="Arial" pitchFamily="34" charset="-122"/>
                 <a:cs typeface="Arial" pitchFamily="34" charset="-120"/>
               </a:rPr>
-              <a:t>The upload form's fields and rules come from a specification</a:t>
+              <a:t>The upload form's fields and rules come from a formal specification</a:t>
             </a:r>
             <a:endParaRPr lang="en-US" sz="1100" dirty="0"/>
           </a:p>
@@ -4132,7 +4154,7 @@
           <a:bodyPr wrap="square" lIns="0" tIns="0" rIns="0" bIns="0" rtlCol="0" anchor="ctr"/>
           <a:lstStyle/>
           <a:p>
-            <a:pPr indent="0" marL="0">
+            <a:pPr marL="0" indent="0">
               <a:buNone/>
             </a:pPr>
             <a:r>
@@ -4146,9 +4168,6 @@
               </a:rPr>
               <a:t>Neuroscience: </a:t>
             </a:r>
-            <a:pPr indent="0" marL="0">
-              <a:buNone/>
-            </a:pPr>
             <a:r>
               <a:rPr lang="en-US" sz="1150" b="1" dirty="0">
                 <a:solidFill>
@@ -4186,6 +4205,13 @@
             <a:prstDash val="solid"/>
           </a:ln>
         </p:spPr>
+        <p:txBody>
+          <a:bodyPr/>
+          <a:lstStyle/>
+          <a:p>
+            <a:endParaRPr lang="en-US"/>
+          </a:p>
+        </p:txBody>
       </p:sp>
       <p:sp>
         <p:nvSpPr>
@@ -4211,6 +4237,13 @@
             <a:prstDash val="solid"/>
           </a:ln>
         </p:spPr>
+        <p:txBody>
+          <a:bodyPr/>
+          <a:lstStyle/>
+          <a:p>
+            <a:endParaRPr lang="en-US"/>
+          </a:p>
+        </p:txBody>
       </p:sp>
       <p:sp>
         <p:nvSpPr>
@@ -4233,7 +4266,7 @@
           <a:bodyPr wrap="square" lIns="0" tIns="0" rIns="0" bIns="0" rtlCol="0" anchor="ctr"/>
           <a:lstStyle/>
           <a:p>
-            <a:pPr algn="ctr" indent="0" marL="0">
+            <a:pPr marL="0" indent="0" algn="ctr">
               <a:buNone/>
             </a:pPr>
             <a:r>
@@ -4248,45 +4281,6 @@
               <a:t>6</a:t>
             </a:r>
             <a:endParaRPr lang="en-US" sz="1200" dirty="0"/>
-          </a:p>
-        </p:txBody>
-      </p:sp>
-      <p:sp>
-        <p:nvSpPr>
-          <p:cNvPr id="103" name="Source note"/>
-          <p:cNvSpPr txBox="1"/>
-          <p:nvPr/>
-        </p:nvSpPr>
-        <p:spPr>
-          <a:xfrm>
-            <a:off x="457200" y="6492240"/>
-            <a:ext cx="11247120" cy="228600"/>
-          </a:xfrm>
-          <a:prstGeom prst="rect">
-            <a:avLst/>
-          </a:prstGeom>
-          <a:noFill/>
-          <a:ln/>
-        </p:spPr>
-        <p:txBody>
-          <a:bodyPr wrap="square" lIns="0" tIns="0" rIns="0" bIns="0" rtlCol="0" anchor="ctr"/>
-          <a:lstStyle/>
-          <a:p>
-            <a:pPr indent="0" marL="0">
-              <a:buNone/>
-            </a:pPr>
-            <a:r>
-              <a:rPr lang="en-US" sz="900" dirty="0">
-                <a:solidFill>
-                  <a:srgbClr val="5B6770"/>
-                </a:solidFill>
-                <a:latin typeface="Arial" pitchFamily="34" charset="0"/>
-                <a:ea typeface="Arial" pitchFamily="34" charset="-122"/>
-                <a:cs typeface="Arial" pitchFamily="34" charset="-120"/>
-              </a:rPr>
-              <a:t>Layer definitions: Table 1 · Legend: draft/12_figures_tables.md · Analogy adapted from the SfN 2025 poster</a:t>
-            </a:r>
-            <a:endParaRPr lang="en-US" sz="900" dirty="0"/>
           </a:p>
         </p:txBody>
       </p:sp>
@@ -4591,4 +4585,319 @@
     </a:ext>
   </a:extLst>
 </a:theme>
+</file>
+
+<file path=ppt/theme/theme2.xml><?xml version="1.0" encoding="utf-8"?>
+<a:theme xmlns:a="http://schemas.openxmlformats.org/drawingml/2006/main" name="Office Theme">
+  <a:themeElements>
+    <a:clrScheme name="Office">
+      <a:dk1>
+        <a:sysClr val="windowText" lastClr="000000"/>
+      </a:dk1>
+      <a:lt1>
+        <a:sysClr val="window" lastClr="FFFFFF"/>
+      </a:lt1>
+      <a:dk2>
+        <a:srgbClr val="0E2841"/>
+      </a:dk2>
+      <a:lt2>
+        <a:srgbClr val="E8E8E8"/>
+      </a:lt2>
+      <a:accent1>
+        <a:srgbClr val="156082"/>
+      </a:accent1>
+      <a:accent2>
+        <a:srgbClr val="E97132"/>
+      </a:accent2>
+      <a:accent3>
+        <a:srgbClr val="196B24"/>
+      </a:accent3>
+      <a:accent4>
+        <a:srgbClr val="0F9ED5"/>
+      </a:accent4>
+      <a:accent5>
+        <a:srgbClr val="A02B93"/>
+      </a:accent5>
+      <a:accent6>
+        <a:srgbClr val="4EA72E"/>
+      </a:accent6>
+      <a:hlink>
+        <a:srgbClr val="467886"/>
+      </a:hlink>
+      <a:folHlink>
+        <a:srgbClr val="96607D"/>
+      </a:folHlink>
+    </a:clrScheme>
+    <a:fontScheme name="Office">
+      <a:majorFont>
+        <a:latin typeface="Aptos Display" panose="02110004020202020204"/>
+        <a:ea typeface=""/>
+        <a:cs typeface=""/>
+        <a:font script="Jpan" typeface="游ゴシック Light"/>
+        <a:font script="Hang" typeface="맑은 고딕"/>
+        <a:font script="Hans" typeface="等线 Light"/>
+        <a:font script="Hant" typeface="新細明體"/>
+        <a:font script="Arab" typeface="Times New Roman"/>
+        <a:font script="Hebr" typeface="Times New Roman"/>
+        <a:font script="Thai" typeface="Angsana New"/>
+        <a:font script="Ethi" typeface="Nyala"/>
+        <a:font script="Beng" typeface="Vrinda"/>
+        <a:font script="Gujr" typeface="Shruti"/>
+        <a:font script="Khmr" typeface="MoolBoran"/>
+        <a:font script="Knda" typeface="Tunga"/>
+        <a:font script="Guru" typeface="Raavi"/>
+        <a:font script="Cans" typeface="Euphemia"/>
+        <a:font script="Cher" typeface="Plantagenet Cherokee"/>
+        <a:font script="Yiii" typeface="Microsoft Yi Baiti"/>
+        <a:font script="Tibt" typeface="Microsoft Himalaya"/>
+        <a:font script="Thaa" typeface="MV Boli"/>
+        <a:font script="Deva" typeface="Mangal"/>
+        <a:font script="Telu" typeface="Gautami"/>
+        <a:font script="Taml" typeface="Latha"/>
+        <a:font script="Syrc" typeface="Estrangelo Edessa"/>
+        <a:font script="Orya" typeface="Kalinga"/>
+        <a:font script="Mlym" typeface="Kartika"/>
+        <a:font script="Laoo" typeface="DokChampa"/>
+        <a:font script="Sinh" typeface="Iskoola Pota"/>
+        <a:font script="Mong" typeface="Mongolian Baiti"/>
+        <a:font script="Viet" typeface="Times New Roman"/>
+        <a:font script="Uigh" typeface="Microsoft Uighur"/>
+        <a:font script="Geor" typeface="Sylfaen"/>
+        <a:font script="Armn" typeface="Arial"/>
+        <a:font script="Bugi" typeface="Leelawadee UI"/>
+        <a:font script="Bopo" typeface="Microsoft JhengHei"/>
+        <a:font script="Java" typeface="Javanese Text"/>
+        <a:font script="Lisu" typeface="Segoe UI"/>
+        <a:font script="Mymr" typeface="Myanmar Text"/>
+        <a:font script="Nkoo" typeface="Ebrima"/>
+        <a:font script="Olck" typeface="Nirmala UI"/>
+        <a:font script="Osma" typeface="Ebrima"/>
+        <a:font script="Phag" typeface="Phagspa"/>
+        <a:font script="Syrn" typeface="Estrangelo Edessa"/>
+        <a:font script="Syrj" typeface="Estrangelo Edessa"/>
+        <a:font script="Syre" typeface="Estrangelo Edessa"/>
+        <a:font script="Sora" typeface="Nirmala UI"/>
+        <a:font script="Tale" typeface="Microsoft Tai Le"/>
+        <a:font script="Talu" typeface="Microsoft New Tai Lue"/>
+        <a:font script="Tfng" typeface="Ebrima"/>
+      </a:majorFont>
+      <a:minorFont>
+        <a:latin typeface="Aptos" panose="02110004020202020204"/>
+        <a:ea typeface=""/>
+        <a:cs typeface=""/>
+        <a:font script="Jpan" typeface="游ゴシック"/>
+        <a:font script="Hang" typeface="맑은 고딕"/>
+        <a:font script="Hans" typeface="等线"/>
+        <a:font script="Hant" typeface="新細明體"/>
+        <a:font script="Arab" typeface="Arial"/>
+        <a:font script="Hebr" typeface="Arial"/>
+        <a:font script="Thai" typeface="Cordia New"/>
+        <a:font script="Ethi" typeface="Nyala"/>
+        <a:font script="Beng" typeface="Vrinda"/>
+        <a:font script="Gujr" typeface="Shruti"/>
+        <a:font script="Khmr" typeface="DaunPenh"/>
+        <a:font script="Knda" typeface="Tunga"/>
+        <a:font script="Guru" typeface="Raavi"/>
+        <a:font script="Cans" typeface="Euphemia"/>
+        <a:font script="Cher" typeface="Plantagenet Cherokee"/>
+        <a:font script="Yiii" typeface="Microsoft Yi Baiti"/>
+        <a:font script="Tibt" typeface="Microsoft Himalaya"/>
+        <a:font script="Thaa" typeface="MV Boli"/>
+        <a:font script="Deva" typeface="Mangal"/>
+        <a:font script="Telu" typeface="Gautami"/>
+        <a:font script="Taml" typeface="Latha"/>
+        <a:font script="Syrc" typeface="Estrangelo Edessa"/>
+        <a:font script="Orya" typeface="Kalinga"/>
+        <a:font script="Mlym" typeface="Kartika"/>
+        <a:font script="Laoo" typeface="DokChampa"/>
+        <a:font script="Sinh" typeface="Iskoola Pota"/>
+        <a:font script="Mong" typeface="Mongolian Baiti"/>
+        <a:font script="Viet" typeface="Arial"/>
+        <a:font script="Uigh" typeface="Microsoft Uighur"/>
+        <a:font script="Geor" typeface="Sylfaen"/>
+        <a:font script="Armn" typeface="Arial"/>
+        <a:font script="Bugi" typeface="Leelawadee UI"/>
+        <a:font script="Bopo" typeface="Microsoft JhengHei"/>
+        <a:font script="Java" typeface="Javanese Text"/>
+        <a:font script="Lisu" typeface="Segoe UI"/>
+        <a:font script="Mymr" typeface="Myanmar Text"/>
+        <a:font script="Nkoo" typeface="Ebrima"/>
+        <a:font script="Olck" typeface="Nirmala UI"/>
+        <a:font script="Osma" typeface="Ebrima"/>
+        <a:font script="Phag" typeface="Phagspa"/>
+        <a:font script="Syrn" typeface="Estrangelo Edessa"/>
+        <a:font script="Syrj" typeface="Estrangelo Edessa"/>
+        <a:font script="Syre" typeface="Estrangelo Edessa"/>
+        <a:font script="Sora" typeface="Nirmala UI"/>
+        <a:font script="Tale" typeface="Microsoft Tai Le"/>
+        <a:font script="Talu" typeface="Microsoft New Tai Lue"/>
+        <a:font script="Tfng" typeface="Ebrima"/>
+      </a:minorFont>
+    </a:fontScheme>
+    <a:fmtScheme name="Office">
+      <a:fillStyleLst>
+        <a:solidFill>
+          <a:schemeClr val="phClr"/>
+        </a:solidFill>
+        <a:gradFill rotWithShape="1">
+          <a:gsLst>
+            <a:gs pos="0">
+              <a:schemeClr val="phClr">
+                <a:lumMod val="110000"/>
+                <a:satMod val="105000"/>
+                <a:tint val="67000"/>
+              </a:schemeClr>
+            </a:gs>
+            <a:gs pos="50000">
+              <a:schemeClr val="phClr">
+                <a:lumMod val="105000"/>
+                <a:satMod val="103000"/>
+                <a:tint val="73000"/>
+              </a:schemeClr>
+            </a:gs>
+            <a:gs pos="100000">
+              <a:schemeClr val="phClr">
+                <a:lumMod val="105000"/>
+                <a:satMod val="109000"/>
+                <a:tint val="81000"/>
+              </a:schemeClr>
+            </a:gs>
+          </a:gsLst>
+          <a:lin ang="5400000" scaled="0"/>
+        </a:gradFill>
+        <a:gradFill rotWithShape="1">
+          <a:gsLst>
+            <a:gs pos="0">
+              <a:schemeClr val="phClr">
+                <a:satMod val="103000"/>
+                <a:lumMod val="102000"/>
+                <a:tint val="94000"/>
+              </a:schemeClr>
+            </a:gs>
+            <a:gs pos="50000">
+              <a:schemeClr val="phClr">
+                <a:satMod val="110000"/>
+                <a:lumMod val="100000"/>
+                <a:shade val="100000"/>
+              </a:schemeClr>
+            </a:gs>
+            <a:gs pos="100000">
+              <a:schemeClr val="phClr">
+                <a:lumMod val="99000"/>
+                <a:satMod val="120000"/>
+                <a:shade val="78000"/>
+              </a:schemeClr>
+            </a:gs>
+          </a:gsLst>
+          <a:lin ang="5400000" scaled="0"/>
+        </a:gradFill>
+      </a:fillStyleLst>
+      <a:lnStyleLst>
+        <a:ln w="12700" cap="flat" cmpd="sng" algn="ctr">
+          <a:solidFill>
+            <a:schemeClr val="phClr"/>
+          </a:solidFill>
+          <a:prstDash val="solid"/>
+          <a:miter lim="800000"/>
+        </a:ln>
+        <a:ln w="19050" cap="flat" cmpd="sng" algn="ctr">
+          <a:solidFill>
+            <a:schemeClr val="phClr"/>
+          </a:solidFill>
+          <a:prstDash val="solid"/>
+          <a:miter lim="800000"/>
+        </a:ln>
+        <a:ln w="25400" cap="flat" cmpd="sng" algn="ctr">
+          <a:solidFill>
+            <a:schemeClr val="phClr"/>
+          </a:solidFill>
+          <a:prstDash val="solid"/>
+          <a:miter lim="800000"/>
+        </a:ln>
+      </a:lnStyleLst>
+      <a:effectStyleLst>
+        <a:effectStyle>
+          <a:effectLst/>
+        </a:effectStyle>
+        <a:effectStyle>
+          <a:effectLst/>
+        </a:effectStyle>
+        <a:effectStyle>
+          <a:effectLst>
+            <a:outerShdw blurRad="57150" dist="19050" dir="5400000" algn="ctr" rotWithShape="0">
+              <a:srgbClr val="000000">
+                <a:alpha val="63000"/>
+              </a:srgbClr>
+            </a:outerShdw>
+          </a:effectLst>
+        </a:effectStyle>
+      </a:effectStyleLst>
+      <a:bgFillStyleLst>
+        <a:solidFill>
+          <a:schemeClr val="phClr"/>
+        </a:solidFill>
+        <a:solidFill>
+          <a:schemeClr val="phClr">
+            <a:tint val="95000"/>
+            <a:satMod val="170000"/>
+          </a:schemeClr>
+        </a:solidFill>
+        <a:gradFill rotWithShape="1">
+          <a:gsLst>
+            <a:gs pos="0">
+              <a:schemeClr val="phClr">
+                <a:tint val="93000"/>
+                <a:satMod val="150000"/>
+                <a:shade val="98000"/>
+                <a:lumMod val="102000"/>
+              </a:schemeClr>
+            </a:gs>
+            <a:gs pos="50000">
+              <a:schemeClr val="phClr">
+                <a:tint val="98000"/>
+                <a:satMod val="130000"/>
+                <a:shade val="90000"/>
+                <a:lumMod val="103000"/>
+              </a:schemeClr>
+            </a:gs>
+            <a:gs pos="100000">
+              <a:schemeClr val="phClr">
+                <a:shade val="63000"/>
+                <a:satMod val="120000"/>
+              </a:schemeClr>
+            </a:gs>
+          </a:gsLst>
+          <a:lin ang="5400000" scaled="0"/>
+        </a:gradFill>
+      </a:bgFillStyleLst>
+    </a:fmtScheme>
+  </a:themeElements>
+  <a:objectDefaults>
+    <a:lnDef>
+      <a:spPr/>
+      <a:bodyPr/>
+      <a:lstStyle/>
+      <a:style>
+        <a:lnRef idx="2">
+          <a:schemeClr val="accent1"/>
+        </a:lnRef>
+        <a:fillRef idx="0">
+          <a:schemeClr val="accent1"/>
+        </a:fillRef>
+        <a:effectRef idx="1">
+          <a:schemeClr val="accent1"/>
+        </a:effectRef>
+        <a:fontRef idx="minor">
+          <a:schemeClr val="tx1"/>
+        </a:fontRef>
+      </a:style>
+    </a:lnDef>
+  </a:objectDefaults>
+  <a:extraClrSchemeLst/>
+  <a:extLst>
+    <a:ext uri="{05A4C25C-085E-4340-85A3-A5531E510DB2}">
+      <thm15:themeFamily xmlns:thm15="http://schemas.microsoft.com/office/thememl/2012/main" name="Office Theme" id="{2E142A2C-CD16-42D6-873A-C26D2A0506FA}" vid="{1BDDFF52-6CD6-40A5-AB3C-68EB2F1E4D0A}"/>
+    </a:ext>
+  </a:extLst>
+</a:theme>
 </file>
</xml_diff>

<commit_message>
Number layers bottom-up to match the levels of FAIRness
1 data formats, 2 file organization, 3 dataset organization, 4 ontologies & terminologies,
5 data archives, 6 schema languages.
- Table 1 reordered with a # column; Section 2 layer paragraphs reordered
- Fig. 1 and Fig. 2: badge numbers updated in place (user edits preserved); Fig. 2 notes
- Fig. 1 caption, Fig. 5 legend, Sections 1 and 9, Fig. 1 README, TODO (log, F9)

Co-Authored-By: Claude Opus 5.5 <noreply@anthropic.com>
</commit_message>
<xml_diff>
--- a/figures/fig1_ecosystem_map/fig1_ecosystem_map_design.pptx
+++ b/figures/fig1_ecosystem_map/fig1_ecosystem_map_design.pptx
@@ -2270,7 +2270,7 @@
       </p:sp>
       <p:sp>
         <p:nvSpPr>
-          <p:cNvPr id="49" name="Callout 1: Data archives"/>
+          <p:cNvPr id="49" name="Callout 5: Data archives"/>
           <p:cNvSpPr/>
           <p:nvPr/>
         </p:nvSpPr>
@@ -2306,7 +2306,7 @@
       </p:sp>
       <p:sp>
         <p:nvSpPr>
-          <p:cNvPr id="50" name="Badge 1"/>
+          <p:cNvPr id="50" name="Badge 5"/>
           <p:cNvSpPr/>
           <p:nvPr/>
         </p:nvSpPr>
@@ -2369,7 +2369,7 @@
                 <a:ea typeface="Arial" pitchFamily="34" charset="-122"/>
                 <a:cs typeface="Arial" pitchFamily="34" charset="-120"/>
               </a:rPr>
-              <a:t>1</a:t>
+              <a:t>5</a:t>
             </a:r>
             <a:endParaRPr lang="en-US" sz="1200" dirty="0"/>
           </a:p>
@@ -2535,7 +2535,7 @@
       </p:sp>
       <p:sp>
         <p:nvSpPr>
-          <p:cNvPr id="56" name="Badge 1"/>
+          <p:cNvPr id="56" name="Badge 5"/>
           <p:cNvSpPr/>
           <p:nvPr/>
         </p:nvSpPr>
@@ -2598,7 +2598,7 @@
                 <a:ea typeface="Arial" pitchFamily="34" charset="-122"/>
                 <a:cs typeface="Arial" pitchFamily="34" charset="-120"/>
               </a:rPr>
-              <a:t>1</a:t>
+              <a:t>5</a:t>
             </a:r>
             <a:endParaRPr lang="en-US" sz="1200" dirty="0"/>
           </a:p>
@@ -2606,7 +2606,7 @@
       </p:sp>
       <p:sp>
         <p:nvSpPr>
-          <p:cNvPr id="58" name="Callout 2: Dataset organization standards"/>
+          <p:cNvPr id="58" name="Callout 3: Dataset organization standards"/>
           <p:cNvSpPr/>
           <p:nvPr/>
         </p:nvSpPr>
@@ -2642,7 +2642,7 @@
       </p:sp>
       <p:sp>
         <p:nvSpPr>
-          <p:cNvPr id="59" name="Badge 2"/>
+          <p:cNvPr id="59" name="Badge 3"/>
           <p:cNvSpPr/>
           <p:nvPr/>
         </p:nvSpPr>
@@ -2705,7 +2705,7 @@
                 <a:ea typeface="Arial" pitchFamily="34" charset="-122"/>
                 <a:cs typeface="Arial" pitchFamily="34" charset="-120"/>
               </a:rPr>
-              <a:t>2</a:t>
+              <a:t>3</a:t>
             </a:r>
             <a:endParaRPr lang="en-US" sz="1200" dirty="0"/>
           </a:p>
@@ -2871,7 +2871,7 @@
       </p:sp>
       <p:sp>
         <p:nvSpPr>
-          <p:cNvPr id="65" name="Badge 2"/>
+          <p:cNvPr id="65" name="Badge 3"/>
           <p:cNvSpPr/>
           <p:nvPr/>
         </p:nvSpPr>
@@ -2934,7 +2934,7 @@
                 <a:ea typeface="Arial" pitchFamily="34" charset="-122"/>
                 <a:cs typeface="Arial" pitchFamily="34" charset="-120"/>
               </a:rPr>
-              <a:t>2</a:t>
+              <a:t>3</a:t>
             </a:r>
             <a:endParaRPr lang="en-US" sz="1200" dirty="0"/>
           </a:p>
@@ -2942,7 +2942,7 @@
       </p:sp>
       <p:sp>
         <p:nvSpPr>
-          <p:cNvPr id="67" name="Callout 3: File organization standards"/>
+          <p:cNvPr id="67" name="Callout 2: File organization standards"/>
           <p:cNvSpPr/>
           <p:nvPr/>
         </p:nvSpPr>
@@ -2978,7 +2978,7 @@
       </p:sp>
       <p:sp>
         <p:nvSpPr>
-          <p:cNvPr id="68" name="Badge 3"/>
+          <p:cNvPr id="68" name="Badge 2"/>
           <p:cNvSpPr/>
           <p:nvPr/>
         </p:nvSpPr>
@@ -3041,7 +3041,7 @@
                 <a:ea typeface="Arial" pitchFamily="34" charset="-122"/>
                 <a:cs typeface="Arial" pitchFamily="34" charset="-120"/>
               </a:rPr>
-              <a:t>3</a:t>
+              <a:t>2</a:t>
             </a:r>
             <a:endParaRPr lang="en-US" sz="1200" dirty="0"/>
           </a:p>
@@ -3207,7 +3207,7 @@
       </p:sp>
       <p:sp>
         <p:nvSpPr>
-          <p:cNvPr id="74" name="Badge 3"/>
+          <p:cNvPr id="74" name="Badge 2"/>
           <p:cNvSpPr/>
           <p:nvPr/>
         </p:nvSpPr>
@@ -3270,7 +3270,7 @@
                 <a:ea typeface="Arial" pitchFamily="34" charset="-122"/>
                 <a:cs typeface="Arial" pitchFamily="34" charset="-120"/>
               </a:rPr>
-              <a:t>3</a:t>
+              <a:t>2</a:t>
             </a:r>
             <a:endParaRPr lang="en-US" sz="1200" dirty="0"/>
           </a:p>
@@ -3614,7 +3614,7 @@
       </p:sp>
       <p:sp>
         <p:nvSpPr>
-          <p:cNvPr id="85" name="Callout 5: Data formats"/>
+          <p:cNvPr id="85" name="Callout 1: Data formats"/>
           <p:cNvSpPr/>
           <p:nvPr/>
         </p:nvSpPr>
@@ -3650,7 +3650,7 @@
       </p:sp>
       <p:sp>
         <p:nvSpPr>
-          <p:cNvPr id="86" name="Badge 5"/>
+          <p:cNvPr id="86" name="Badge 1"/>
           <p:cNvSpPr/>
           <p:nvPr/>
         </p:nvSpPr>
@@ -3713,7 +3713,7 @@
                 <a:ea typeface="Arial" pitchFamily="34" charset="-122"/>
                 <a:cs typeface="Arial" pitchFamily="34" charset="-120"/>
               </a:rPr>
-              <a:t>5</a:t>
+              <a:t>1</a:t>
             </a:r>
             <a:endParaRPr lang="en-US" sz="1200" dirty="0"/>
           </a:p>
@@ -3879,7 +3879,7 @@
       </p:sp>
       <p:sp>
         <p:nvSpPr>
-          <p:cNvPr id="92" name="Badge 5"/>
+          <p:cNvPr id="92" name="Badge 1"/>
           <p:cNvSpPr/>
           <p:nvPr/>
         </p:nvSpPr>
@@ -3942,7 +3942,7 @@
                 <a:ea typeface="Arial" pitchFamily="34" charset="-122"/>
                 <a:cs typeface="Arial" pitchFamily="34" charset="-120"/>
               </a:rPr>
-              <a:t>5</a:t>
+              <a:t>1</a:t>
             </a:r>
             <a:endParaRPr lang="en-US" sz="1200" dirty="0"/>
           </a:p>

</xml_diff>